<commit_message>
Fix presentation slide numbering
Co-authored-by: TheXKnight117 <TheXKnight117@users.noreply.github.com>
</commit_message>
<xml_diff>
--- a/S2_Bañares_Requerimientos_Registro_Usuario.pptx
+++ b/S2_Bañares_Requerimientos_Registro_Usuario.pptx
@@ -3914,42 +3914,7 @@
       </p:sp>
       <p:sp>
         <p:nvSpPr>
-          <p:cNvPr id="5" name="TextBox 4"/>
-          <p:cNvSpPr txBox="1"/>
-          <p:nvPr/>
-        </p:nvSpPr>
-        <p:spPr>
-          <a:xfrm>
-            <a:off x="11201400" y="438912"/>
-            <a:ext cx="438912" cy="438912"/>
-          </a:xfrm>
-          <a:prstGeom prst="rect">
-            <a:avLst/>
-          </a:prstGeom>
-          <a:noFill/>
-        </p:spPr>
-        <p:txBody>
-          <a:bodyPr wrap="none" lIns="73152" rIns="73152" tIns="73152" bIns="73152" anchor="ctr">
-            <a:spAutoFit/>
-          </a:bodyPr>
-          <a:lstStyle/>
-          <a:p>
-            <a:pPr algn="ctr"/>
-            <a:r>
-              <a:rPr sz="1300" b="1">
-                <a:solidFill>
-                  <a:srgbClr val="FFFFFF"/>
-                </a:solidFill>
-                <a:latin typeface="Aptos"/>
-              </a:rPr>
-              <a:t>02</a:t>
-            </a:r>
-          </a:p>
-        </p:txBody>
-      </p:sp>
-      <p:sp>
-        <p:nvSpPr>
-          <p:cNvPr id="6" name="Rounded Rectangle 5"/>
+          <p:cNvPr id="5" name="Rounded Rectangle 4"/>
           <p:cNvSpPr/>
           <p:nvPr/>
         </p:nvSpPr>
@@ -4003,7 +3968,7 @@
       </p:sp>
       <p:sp>
         <p:nvSpPr>
-          <p:cNvPr id="7" name="Rounded Rectangle 6"/>
+          <p:cNvPr id="6" name="Rounded Rectangle 5"/>
           <p:cNvSpPr/>
           <p:nvPr/>
         </p:nvSpPr>
@@ -4125,7 +4090,7 @@
       </p:sp>
       <p:sp>
         <p:nvSpPr>
-          <p:cNvPr id="8" name="Rounded Rectangle 7"/>
+          <p:cNvPr id="7" name="Rounded Rectangle 6"/>
           <p:cNvSpPr/>
           <p:nvPr/>
         </p:nvSpPr>
@@ -4170,7 +4135,7 @@
       </p:sp>
       <p:sp>
         <p:nvSpPr>
-          <p:cNvPr id="9" name="Oval 8"/>
+          <p:cNvPr id="8" name="Oval 7"/>
           <p:cNvSpPr/>
           <p:nvPr/>
         </p:nvSpPr>
@@ -4224,7 +4189,7 @@
       </p:sp>
       <p:sp>
         <p:nvSpPr>
-          <p:cNvPr id="10" name="TextBox 9"/>
+          <p:cNvPr id="9" name="TextBox 8"/>
           <p:cNvSpPr txBox="1"/>
           <p:nvPr/>
         </p:nvSpPr>
@@ -4259,7 +4224,7 @@
       </p:sp>
       <p:sp>
         <p:nvSpPr>
-          <p:cNvPr id="11" name="TextBox 10"/>
+          <p:cNvPr id="10" name="TextBox 9"/>
           <p:cNvSpPr txBox="1"/>
           <p:nvPr/>
         </p:nvSpPr>
@@ -4294,7 +4259,7 @@
       </p:sp>
       <p:sp>
         <p:nvSpPr>
-          <p:cNvPr id="12" name="Oval 11"/>
+          <p:cNvPr id="11" name="Oval 10"/>
           <p:cNvSpPr/>
           <p:nvPr/>
         </p:nvSpPr>
@@ -4348,7 +4313,7 @@
       </p:sp>
       <p:sp>
         <p:nvSpPr>
-          <p:cNvPr id="13" name="TextBox 12"/>
+          <p:cNvPr id="12" name="TextBox 11"/>
           <p:cNvSpPr txBox="1"/>
           <p:nvPr/>
         </p:nvSpPr>
@@ -4383,7 +4348,7 @@
       </p:sp>
       <p:sp>
         <p:nvSpPr>
-          <p:cNvPr id="14" name="TextBox 13"/>
+          <p:cNvPr id="13" name="TextBox 12"/>
           <p:cNvSpPr txBox="1"/>
           <p:nvPr/>
         </p:nvSpPr>
@@ -4418,7 +4383,7 @@
       </p:sp>
       <p:sp>
         <p:nvSpPr>
-          <p:cNvPr id="15" name="Oval 14"/>
+          <p:cNvPr id="14" name="Oval 13"/>
           <p:cNvSpPr/>
           <p:nvPr/>
         </p:nvSpPr>
@@ -4472,7 +4437,7 @@
       </p:sp>
       <p:sp>
         <p:nvSpPr>
-          <p:cNvPr id="16" name="TextBox 15"/>
+          <p:cNvPr id="15" name="TextBox 14"/>
           <p:cNvSpPr txBox="1"/>
           <p:nvPr/>
         </p:nvSpPr>
@@ -4507,7 +4472,7 @@
       </p:sp>
       <p:sp>
         <p:nvSpPr>
-          <p:cNvPr id="17" name="TextBox 16"/>
+          <p:cNvPr id="16" name="TextBox 15"/>
           <p:cNvSpPr txBox="1"/>
           <p:nvPr/>
         </p:nvSpPr>
@@ -4542,7 +4507,7 @@
       </p:sp>
       <p:sp>
         <p:nvSpPr>
-          <p:cNvPr id="18" name="Oval 17"/>
+          <p:cNvPr id="17" name="Oval 16"/>
           <p:cNvSpPr/>
           <p:nvPr/>
         </p:nvSpPr>
@@ -4596,7 +4561,7 @@
       </p:sp>
       <p:sp>
         <p:nvSpPr>
-          <p:cNvPr id="19" name="TextBox 18"/>
+          <p:cNvPr id="18" name="TextBox 17"/>
           <p:cNvSpPr txBox="1"/>
           <p:nvPr/>
         </p:nvSpPr>
@@ -4631,7 +4596,7 @@
       </p:sp>
       <p:sp>
         <p:nvSpPr>
-          <p:cNvPr id="20" name="TextBox 19"/>
+          <p:cNvPr id="19" name="TextBox 18"/>
           <p:cNvSpPr txBox="1"/>
           <p:nvPr/>
         </p:nvSpPr>
@@ -4799,42 +4764,7 @@
       </p:sp>
       <p:sp>
         <p:nvSpPr>
-          <p:cNvPr id="5" name="TextBox 4"/>
-          <p:cNvSpPr txBox="1"/>
-          <p:nvPr/>
-        </p:nvSpPr>
-        <p:spPr>
-          <a:xfrm>
-            <a:off x="11201400" y="438912"/>
-            <a:ext cx="438912" cy="438912"/>
-          </a:xfrm>
-          <a:prstGeom prst="rect">
-            <a:avLst/>
-          </a:prstGeom>
-          <a:noFill/>
-        </p:spPr>
-        <p:txBody>
-          <a:bodyPr wrap="none" lIns="73152" rIns="73152" tIns="73152" bIns="73152" anchor="ctr">
-            <a:spAutoFit/>
-          </a:bodyPr>
-          <a:lstStyle/>
-          <a:p>
-            <a:pPr algn="ctr"/>
-            <a:r>
-              <a:rPr sz="1300" b="1">
-                <a:solidFill>
-                  <a:srgbClr val="FFFFFF"/>
-                </a:solidFill>
-                <a:latin typeface="Aptos"/>
-              </a:rPr>
-              <a:t>03</a:t>
-            </a:r>
-          </a:p>
-        </p:txBody>
-      </p:sp>
-      <p:sp>
-        <p:nvSpPr>
-          <p:cNvPr id="6" name="Rounded Rectangle 5"/>
+          <p:cNvPr id="5" name="Rounded Rectangle 4"/>
           <p:cNvSpPr/>
           <p:nvPr/>
         </p:nvSpPr>
@@ -4888,7 +4818,7 @@
       </p:sp>
       <p:sp>
         <p:nvSpPr>
-          <p:cNvPr id="7" name="Rounded Rectangle 6"/>
+          <p:cNvPr id="6" name="Rounded Rectangle 5"/>
           <p:cNvSpPr/>
           <p:nvPr/>
         </p:nvSpPr>
@@ -4933,7 +4863,7 @@
       </p:sp>
       <p:sp>
         <p:nvSpPr>
-          <p:cNvPr id="8" name="Rounded Rectangle 7"/>
+          <p:cNvPr id="7" name="Rounded Rectangle 6"/>
           <p:cNvSpPr/>
           <p:nvPr/>
         </p:nvSpPr>
@@ -4978,7 +4908,7 @@
       </p:sp>
       <p:sp>
         <p:nvSpPr>
-          <p:cNvPr id="9" name="TextBox 8"/>
+          <p:cNvPr id="8" name="TextBox 7"/>
           <p:cNvSpPr txBox="1"/>
           <p:nvPr/>
         </p:nvSpPr>
@@ -5013,7 +4943,7 @@
       </p:sp>
       <p:sp>
         <p:nvSpPr>
-          <p:cNvPr id="10" name="Rounded Rectangle 9"/>
+          <p:cNvPr id="9" name="Rounded Rectangle 8"/>
           <p:cNvSpPr/>
           <p:nvPr/>
         </p:nvSpPr>
@@ -5067,7 +4997,7 @@
       </p:sp>
       <p:sp>
         <p:nvSpPr>
-          <p:cNvPr id="11" name="TextBox 10"/>
+          <p:cNvPr id="10" name="TextBox 9"/>
           <p:cNvSpPr txBox="1"/>
           <p:nvPr/>
         </p:nvSpPr>
@@ -5102,7 +5032,7 @@
       </p:sp>
       <p:sp>
         <p:nvSpPr>
-          <p:cNvPr id="12" name="TextBox 11"/>
+          <p:cNvPr id="11" name="TextBox 10"/>
           <p:cNvSpPr txBox="1"/>
           <p:nvPr/>
         </p:nvSpPr>
@@ -5137,7 +5067,7 @@
       </p:sp>
       <p:sp>
         <p:nvSpPr>
-          <p:cNvPr id="13" name="TextBox 12"/>
+          <p:cNvPr id="12" name="TextBox 11"/>
           <p:cNvSpPr txBox="1"/>
           <p:nvPr/>
         </p:nvSpPr>
@@ -5172,7 +5102,7 @@
       </p:sp>
       <p:sp>
         <p:nvSpPr>
-          <p:cNvPr id="14" name="Rounded Rectangle 13"/>
+          <p:cNvPr id="13" name="Rounded Rectangle 12"/>
           <p:cNvSpPr/>
           <p:nvPr/>
         </p:nvSpPr>
@@ -5217,7 +5147,7 @@
       </p:sp>
       <p:sp>
         <p:nvSpPr>
-          <p:cNvPr id="15" name="Rounded Rectangle 14"/>
+          <p:cNvPr id="14" name="Rounded Rectangle 13"/>
           <p:cNvSpPr/>
           <p:nvPr/>
         </p:nvSpPr>
@@ -5262,7 +5192,7 @@
       </p:sp>
       <p:sp>
         <p:nvSpPr>
-          <p:cNvPr id="16" name="TextBox 15"/>
+          <p:cNvPr id="15" name="TextBox 14"/>
           <p:cNvSpPr txBox="1"/>
           <p:nvPr/>
         </p:nvSpPr>
@@ -5297,7 +5227,7 @@
       </p:sp>
       <p:sp>
         <p:nvSpPr>
-          <p:cNvPr id="17" name="Rounded Rectangle 16"/>
+          <p:cNvPr id="16" name="Rounded Rectangle 15"/>
           <p:cNvSpPr/>
           <p:nvPr/>
         </p:nvSpPr>
@@ -5351,7 +5281,7 @@
       </p:sp>
       <p:sp>
         <p:nvSpPr>
-          <p:cNvPr id="18" name="TextBox 17"/>
+          <p:cNvPr id="17" name="TextBox 16"/>
           <p:cNvSpPr txBox="1"/>
           <p:nvPr/>
         </p:nvSpPr>
@@ -5386,7 +5316,7 @@
       </p:sp>
       <p:sp>
         <p:nvSpPr>
-          <p:cNvPr id="19" name="TextBox 18"/>
+          <p:cNvPr id="18" name="TextBox 17"/>
           <p:cNvSpPr txBox="1"/>
           <p:nvPr/>
         </p:nvSpPr>
@@ -5421,7 +5351,7 @@
       </p:sp>
       <p:sp>
         <p:nvSpPr>
-          <p:cNvPr id="20" name="TextBox 19"/>
+          <p:cNvPr id="19" name="TextBox 18"/>
           <p:cNvSpPr txBox="1"/>
           <p:nvPr/>
         </p:nvSpPr>
@@ -5456,7 +5386,7 @@
       </p:sp>
       <p:sp>
         <p:nvSpPr>
-          <p:cNvPr id="21" name="Rounded Rectangle 20"/>
+          <p:cNvPr id="20" name="Rounded Rectangle 19"/>
           <p:cNvSpPr/>
           <p:nvPr/>
         </p:nvSpPr>
@@ -5501,7 +5431,7 @@
       </p:sp>
       <p:sp>
         <p:nvSpPr>
-          <p:cNvPr id="22" name="Rounded Rectangle 21"/>
+          <p:cNvPr id="21" name="Rounded Rectangle 20"/>
           <p:cNvSpPr/>
           <p:nvPr/>
         </p:nvSpPr>
@@ -5546,7 +5476,7 @@
       </p:sp>
       <p:sp>
         <p:nvSpPr>
-          <p:cNvPr id="23" name="TextBox 22"/>
+          <p:cNvPr id="22" name="TextBox 21"/>
           <p:cNvSpPr txBox="1"/>
           <p:nvPr/>
         </p:nvSpPr>
@@ -5581,7 +5511,7 @@
       </p:sp>
       <p:sp>
         <p:nvSpPr>
-          <p:cNvPr id="24" name="Rounded Rectangle 23"/>
+          <p:cNvPr id="23" name="Rounded Rectangle 22"/>
           <p:cNvSpPr/>
           <p:nvPr/>
         </p:nvSpPr>
@@ -5635,7 +5565,7 @@
       </p:sp>
       <p:sp>
         <p:nvSpPr>
-          <p:cNvPr id="25" name="TextBox 24"/>
+          <p:cNvPr id="24" name="TextBox 23"/>
           <p:cNvSpPr txBox="1"/>
           <p:nvPr/>
         </p:nvSpPr>
@@ -5670,7 +5600,7 @@
       </p:sp>
       <p:sp>
         <p:nvSpPr>
-          <p:cNvPr id="26" name="TextBox 25"/>
+          <p:cNvPr id="25" name="TextBox 24"/>
           <p:cNvSpPr txBox="1"/>
           <p:nvPr/>
         </p:nvSpPr>
@@ -5705,7 +5635,7 @@
       </p:sp>
       <p:sp>
         <p:nvSpPr>
-          <p:cNvPr id="27" name="TextBox 26"/>
+          <p:cNvPr id="26" name="TextBox 25"/>
           <p:cNvSpPr txBox="1"/>
           <p:nvPr/>
         </p:nvSpPr>
@@ -5740,7 +5670,7 @@
       </p:sp>
       <p:sp>
         <p:nvSpPr>
-          <p:cNvPr id="28" name="Rounded Rectangle 27"/>
+          <p:cNvPr id="27" name="Rounded Rectangle 26"/>
           <p:cNvSpPr/>
           <p:nvPr/>
         </p:nvSpPr>
@@ -5785,7 +5715,7 @@
       </p:sp>
       <p:sp>
         <p:nvSpPr>
-          <p:cNvPr id="29" name="Rounded Rectangle 28"/>
+          <p:cNvPr id="28" name="Rounded Rectangle 27"/>
           <p:cNvSpPr/>
           <p:nvPr/>
         </p:nvSpPr>
@@ -5830,7 +5760,7 @@
       </p:sp>
       <p:sp>
         <p:nvSpPr>
-          <p:cNvPr id="30" name="TextBox 29"/>
+          <p:cNvPr id="29" name="TextBox 28"/>
           <p:cNvSpPr txBox="1"/>
           <p:nvPr/>
         </p:nvSpPr>
@@ -5865,7 +5795,7 @@
       </p:sp>
       <p:sp>
         <p:nvSpPr>
-          <p:cNvPr id="31" name="Rounded Rectangle 30"/>
+          <p:cNvPr id="30" name="Rounded Rectangle 29"/>
           <p:cNvSpPr/>
           <p:nvPr/>
         </p:nvSpPr>
@@ -5919,7 +5849,7 @@
       </p:sp>
       <p:sp>
         <p:nvSpPr>
-          <p:cNvPr id="32" name="TextBox 31"/>
+          <p:cNvPr id="31" name="TextBox 30"/>
           <p:cNvSpPr txBox="1"/>
           <p:nvPr/>
         </p:nvSpPr>
@@ -5954,7 +5884,7 @@
       </p:sp>
       <p:sp>
         <p:nvSpPr>
-          <p:cNvPr id="33" name="TextBox 32"/>
+          <p:cNvPr id="32" name="TextBox 31"/>
           <p:cNvSpPr txBox="1"/>
           <p:nvPr/>
         </p:nvSpPr>
@@ -5989,7 +5919,7 @@
       </p:sp>
       <p:sp>
         <p:nvSpPr>
-          <p:cNvPr id="34" name="TextBox 33"/>
+          <p:cNvPr id="33" name="TextBox 32"/>
           <p:cNvSpPr txBox="1"/>
           <p:nvPr/>
         </p:nvSpPr>
@@ -6024,7 +5954,7 @@
       </p:sp>
       <p:sp>
         <p:nvSpPr>
-          <p:cNvPr id="35" name="TextBox 34"/>
+          <p:cNvPr id="34" name="TextBox 33"/>
           <p:cNvSpPr txBox="1"/>
           <p:nvPr/>
         </p:nvSpPr>
@@ -6192,42 +6122,7 @@
       </p:sp>
       <p:sp>
         <p:nvSpPr>
-          <p:cNvPr id="5" name="TextBox 4"/>
-          <p:cNvSpPr txBox="1"/>
-          <p:nvPr/>
-        </p:nvSpPr>
-        <p:spPr>
-          <a:xfrm>
-            <a:off x="11201400" y="438912"/>
-            <a:ext cx="438912" cy="438912"/>
-          </a:xfrm>
-          <a:prstGeom prst="rect">
-            <a:avLst/>
-          </a:prstGeom>
-          <a:noFill/>
-        </p:spPr>
-        <p:txBody>
-          <a:bodyPr wrap="none" lIns="73152" rIns="73152" tIns="73152" bIns="73152" anchor="ctr">
-            <a:spAutoFit/>
-          </a:bodyPr>
-          <a:lstStyle/>
-          <a:p>
-            <a:pPr algn="ctr"/>
-            <a:r>
-              <a:rPr sz="1300" b="1">
-                <a:solidFill>
-                  <a:srgbClr val="FFFFFF"/>
-                </a:solidFill>
-                <a:latin typeface="Aptos"/>
-              </a:rPr>
-              <a:t>04</a:t>
-            </a:r>
-          </a:p>
-        </p:txBody>
-      </p:sp>
-      <p:sp>
-        <p:nvSpPr>
-          <p:cNvPr id="6" name="Rounded Rectangle 5"/>
+          <p:cNvPr id="5" name="Rounded Rectangle 4"/>
           <p:cNvSpPr/>
           <p:nvPr/>
         </p:nvSpPr>
@@ -6281,7 +6176,7 @@
       </p:sp>
       <p:sp>
         <p:nvSpPr>
-          <p:cNvPr id="7" name="Rounded Rectangle 6"/>
+          <p:cNvPr id="6" name="Rounded Rectangle 5"/>
           <p:cNvSpPr/>
           <p:nvPr/>
         </p:nvSpPr>
@@ -6326,7 +6221,7 @@
       </p:sp>
       <p:sp>
         <p:nvSpPr>
-          <p:cNvPr id="8" name="Rounded Rectangle 7"/>
+          <p:cNvPr id="7" name="Rounded Rectangle 6"/>
           <p:cNvSpPr/>
           <p:nvPr/>
         </p:nvSpPr>
@@ -6371,7 +6266,7 @@
       </p:sp>
       <p:sp>
         <p:nvSpPr>
-          <p:cNvPr id="9" name="TextBox 8"/>
+          <p:cNvPr id="8" name="TextBox 7"/>
           <p:cNvSpPr txBox="1"/>
           <p:nvPr/>
         </p:nvSpPr>
@@ -6406,7 +6301,7 @@
       </p:sp>
       <p:sp>
         <p:nvSpPr>
-          <p:cNvPr id="10" name="Rounded Rectangle 9"/>
+          <p:cNvPr id="9" name="Rounded Rectangle 8"/>
           <p:cNvSpPr/>
           <p:nvPr/>
         </p:nvSpPr>
@@ -6460,7 +6355,7 @@
       </p:sp>
       <p:sp>
         <p:nvSpPr>
-          <p:cNvPr id="11" name="TextBox 10"/>
+          <p:cNvPr id="10" name="TextBox 9"/>
           <p:cNvSpPr txBox="1"/>
           <p:nvPr/>
         </p:nvSpPr>
@@ -6495,7 +6390,7 @@
       </p:sp>
       <p:sp>
         <p:nvSpPr>
-          <p:cNvPr id="12" name="TextBox 11"/>
+          <p:cNvPr id="11" name="TextBox 10"/>
           <p:cNvSpPr txBox="1"/>
           <p:nvPr/>
         </p:nvSpPr>
@@ -6530,7 +6425,7 @@
       </p:sp>
       <p:sp>
         <p:nvSpPr>
-          <p:cNvPr id="13" name="TextBox 12"/>
+          <p:cNvPr id="12" name="TextBox 11"/>
           <p:cNvSpPr txBox="1"/>
           <p:nvPr/>
         </p:nvSpPr>
@@ -6565,7 +6460,7 @@
       </p:sp>
       <p:sp>
         <p:nvSpPr>
-          <p:cNvPr id="14" name="Rounded Rectangle 13"/>
+          <p:cNvPr id="13" name="Rounded Rectangle 12"/>
           <p:cNvSpPr/>
           <p:nvPr/>
         </p:nvSpPr>
@@ -6610,7 +6505,7 @@
       </p:sp>
       <p:sp>
         <p:nvSpPr>
-          <p:cNvPr id="15" name="Rounded Rectangle 14"/>
+          <p:cNvPr id="14" name="Rounded Rectangle 13"/>
           <p:cNvSpPr/>
           <p:nvPr/>
         </p:nvSpPr>
@@ -6655,7 +6550,7 @@
       </p:sp>
       <p:sp>
         <p:nvSpPr>
-          <p:cNvPr id="16" name="TextBox 15"/>
+          <p:cNvPr id="15" name="TextBox 14"/>
           <p:cNvSpPr txBox="1"/>
           <p:nvPr/>
         </p:nvSpPr>
@@ -6690,7 +6585,7 @@
       </p:sp>
       <p:sp>
         <p:nvSpPr>
-          <p:cNvPr id="17" name="Rounded Rectangle 16"/>
+          <p:cNvPr id="16" name="Rounded Rectangle 15"/>
           <p:cNvSpPr/>
           <p:nvPr/>
         </p:nvSpPr>
@@ -6744,7 +6639,7 @@
       </p:sp>
       <p:sp>
         <p:nvSpPr>
-          <p:cNvPr id="18" name="TextBox 17"/>
+          <p:cNvPr id="17" name="TextBox 16"/>
           <p:cNvSpPr txBox="1"/>
           <p:nvPr/>
         </p:nvSpPr>
@@ -6779,7 +6674,7 @@
       </p:sp>
       <p:sp>
         <p:nvSpPr>
-          <p:cNvPr id="19" name="TextBox 18"/>
+          <p:cNvPr id="18" name="TextBox 17"/>
           <p:cNvSpPr txBox="1"/>
           <p:nvPr/>
         </p:nvSpPr>
@@ -6814,7 +6709,7 @@
       </p:sp>
       <p:sp>
         <p:nvSpPr>
-          <p:cNvPr id="20" name="TextBox 19"/>
+          <p:cNvPr id="19" name="TextBox 18"/>
           <p:cNvSpPr txBox="1"/>
           <p:nvPr/>
         </p:nvSpPr>
@@ -6849,7 +6744,7 @@
       </p:sp>
       <p:sp>
         <p:nvSpPr>
-          <p:cNvPr id="21" name="Rounded Rectangle 20"/>
+          <p:cNvPr id="20" name="Rounded Rectangle 19"/>
           <p:cNvSpPr/>
           <p:nvPr/>
         </p:nvSpPr>
@@ -6894,7 +6789,7 @@
       </p:sp>
       <p:sp>
         <p:nvSpPr>
-          <p:cNvPr id="22" name="Rounded Rectangle 21"/>
+          <p:cNvPr id="21" name="Rounded Rectangle 20"/>
           <p:cNvSpPr/>
           <p:nvPr/>
         </p:nvSpPr>
@@ -6939,7 +6834,7 @@
       </p:sp>
       <p:sp>
         <p:nvSpPr>
-          <p:cNvPr id="23" name="TextBox 22"/>
+          <p:cNvPr id="22" name="TextBox 21"/>
           <p:cNvSpPr txBox="1"/>
           <p:nvPr/>
         </p:nvSpPr>
@@ -6974,7 +6869,7 @@
       </p:sp>
       <p:sp>
         <p:nvSpPr>
-          <p:cNvPr id="24" name="Rounded Rectangle 23"/>
+          <p:cNvPr id="23" name="Rounded Rectangle 22"/>
           <p:cNvSpPr/>
           <p:nvPr/>
         </p:nvSpPr>
@@ -7028,7 +6923,7 @@
       </p:sp>
       <p:sp>
         <p:nvSpPr>
-          <p:cNvPr id="25" name="TextBox 24"/>
+          <p:cNvPr id="24" name="TextBox 23"/>
           <p:cNvSpPr txBox="1"/>
           <p:nvPr/>
         </p:nvSpPr>
@@ -7063,7 +6958,7 @@
       </p:sp>
       <p:sp>
         <p:nvSpPr>
-          <p:cNvPr id="26" name="TextBox 25"/>
+          <p:cNvPr id="25" name="TextBox 24"/>
           <p:cNvSpPr txBox="1"/>
           <p:nvPr/>
         </p:nvSpPr>
@@ -7098,7 +6993,7 @@
       </p:sp>
       <p:sp>
         <p:nvSpPr>
-          <p:cNvPr id="27" name="TextBox 26"/>
+          <p:cNvPr id="26" name="TextBox 25"/>
           <p:cNvSpPr txBox="1"/>
           <p:nvPr/>
         </p:nvSpPr>
@@ -7133,7 +7028,7 @@
       </p:sp>
       <p:sp>
         <p:nvSpPr>
-          <p:cNvPr id="28" name="Rounded Rectangle 27"/>
+          <p:cNvPr id="27" name="Rounded Rectangle 26"/>
           <p:cNvSpPr/>
           <p:nvPr/>
         </p:nvSpPr>
@@ -7178,7 +7073,7 @@
       </p:sp>
       <p:sp>
         <p:nvSpPr>
-          <p:cNvPr id="29" name="Rounded Rectangle 28"/>
+          <p:cNvPr id="28" name="Rounded Rectangle 27"/>
           <p:cNvSpPr/>
           <p:nvPr/>
         </p:nvSpPr>
@@ -7223,7 +7118,7 @@
       </p:sp>
       <p:sp>
         <p:nvSpPr>
-          <p:cNvPr id="30" name="TextBox 29"/>
+          <p:cNvPr id="29" name="TextBox 28"/>
           <p:cNvSpPr txBox="1"/>
           <p:nvPr/>
         </p:nvSpPr>
@@ -7258,7 +7153,7 @@
       </p:sp>
       <p:sp>
         <p:nvSpPr>
-          <p:cNvPr id="31" name="Rounded Rectangle 30"/>
+          <p:cNvPr id="30" name="Rounded Rectangle 29"/>
           <p:cNvSpPr/>
           <p:nvPr/>
         </p:nvSpPr>
@@ -7312,7 +7207,7 @@
       </p:sp>
       <p:sp>
         <p:nvSpPr>
-          <p:cNvPr id="32" name="TextBox 31"/>
+          <p:cNvPr id="31" name="TextBox 30"/>
           <p:cNvSpPr txBox="1"/>
           <p:nvPr/>
         </p:nvSpPr>
@@ -7347,7 +7242,7 @@
       </p:sp>
       <p:sp>
         <p:nvSpPr>
-          <p:cNvPr id="33" name="TextBox 32"/>
+          <p:cNvPr id="32" name="TextBox 31"/>
           <p:cNvSpPr txBox="1"/>
           <p:nvPr/>
         </p:nvSpPr>
@@ -7382,7 +7277,7 @@
       </p:sp>
       <p:sp>
         <p:nvSpPr>
-          <p:cNvPr id="34" name="TextBox 33"/>
+          <p:cNvPr id="33" name="TextBox 32"/>
           <p:cNvSpPr txBox="1"/>
           <p:nvPr/>
         </p:nvSpPr>
@@ -7417,7 +7312,7 @@
       </p:sp>
       <p:sp>
         <p:nvSpPr>
-          <p:cNvPr id="35" name="TextBox 34"/>
+          <p:cNvPr id="34" name="TextBox 33"/>
           <p:cNvSpPr txBox="1"/>
           <p:nvPr/>
         </p:nvSpPr>
@@ -7585,42 +7480,7 @@
       </p:sp>
       <p:sp>
         <p:nvSpPr>
-          <p:cNvPr id="5" name="TextBox 4"/>
-          <p:cNvSpPr txBox="1"/>
-          <p:nvPr/>
-        </p:nvSpPr>
-        <p:spPr>
-          <a:xfrm>
-            <a:off x="11201400" y="438912"/>
-            <a:ext cx="438912" cy="438912"/>
-          </a:xfrm>
-          <a:prstGeom prst="rect">
-            <a:avLst/>
-          </a:prstGeom>
-          <a:noFill/>
-        </p:spPr>
-        <p:txBody>
-          <a:bodyPr wrap="none" lIns="73152" rIns="73152" tIns="73152" bIns="73152" anchor="ctr">
-            <a:spAutoFit/>
-          </a:bodyPr>
-          <a:lstStyle/>
-          <a:p>
-            <a:pPr algn="ctr"/>
-            <a:r>
-              <a:rPr sz="1300" b="1">
-                <a:solidFill>
-                  <a:srgbClr val="FFFFFF"/>
-                </a:solidFill>
-                <a:latin typeface="Aptos"/>
-              </a:rPr>
-              <a:t>05</a:t>
-            </a:r>
-          </a:p>
-        </p:txBody>
-      </p:sp>
-      <p:sp>
-        <p:nvSpPr>
-          <p:cNvPr id="6" name="Rounded Rectangle 5"/>
+          <p:cNvPr id="5" name="Rounded Rectangle 4"/>
           <p:cNvSpPr/>
           <p:nvPr/>
         </p:nvSpPr>
@@ -7674,7 +7534,7 @@
       </p:sp>
       <p:sp>
         <p:nvSpPr>
-          <p:cNvPr id="7" name="Rounded Rectangle 6"/>
+          <p:cNvPr id="6" name="Rounded Rectangle 5"/>
           <p:cNvSpPr/>
           <p:nvPr/>
         </p:nvSpPr>
@@ -7812,7 +7672,7 @@
       </p:sp>
       <p:sp>
         <p:nvSpPr>
-          <p:cNvPr id="8" name="Rounded Rectangle 7"/>
+          <p:cNvPr id="7" name="Rounded Rectangle 6"/>
           <p:cNvSpPr/>
           <p:nvPr/>
         </p:nvSpPr>
@@ -7950,7 +7810,7 @@
       </p:sp>
       <p:sp>
         <p:nvSpPr>
-          <p:cNvPr id="9" name="TextBox 8"/>
+          <p:cNvPr id="8" name="TextBox 7"/>
           <p:cNvSpPr txBox="1"/>
           <p:nvPr/>
         </p:nvSpPr>
@@ -7985,7 +7845,7 @@
       </p:sp>
       <p:sp>
         <p:nvSpPr>
-          <p:cNvPr id="10" name="TextBox 9"/>
+          <p:cNvPr id="9" name="TextBox 8"/>
           <p:cNvSpPr txBox="1"/>
           <p:nvPr/>
         </p:nvSpPr>
@@ -8020,7 +7880,7 @@
       </p:sp>
       <p:sp>
         <p:nvSpPr>
-          <p:cNvPr id="11" name="Rounded Rectangle 10"/>
+          <p:cNvPr id="10" name="Rounded Rectangle 9"/>
           <p:cNvSpPr/>
           <p:nvPr/>
         </p:nvSpPr>
@@ -8076,7 +7936,7 @@
       </p:sp>
       <p:sp>
         <p:nvSpPr>
-          <p:cNvPr id="12" name="TextBox 11"/>
+          <p:cNvPr id="11" name="TextBox 10"/>
           <p:cNvSpPr txBox="1"/>
           <p:nvPr/>
         </p:nvSpPr>
@@ -8112,7 +7972,7 @@
       </p:sp>
       <p:sp>
         <p:nvSpPr>
-          <p:cNvPr id="13" name="TextBox 12"/>
+          <p:cNvPr id="12" name="TextBox 11"/>
           <p:cNvSpPr txBox="1"/>
           <p:nvPr/>
         </p:nvSpPr>
@@ -8280,42 +8140,7 @@
       </p:sp>
       <p:sp>
         <p:nvSpPr>
-          <p:cNvPr id="5" name="TextBox 4"/>
-          <p:cNvSpPr txBox="1"/>
-          <p:nvPr/>
-        </p:nvSpPr>
-        <p:spPr>
-          <a:xfrm>
-            <a:off x="11201400" y="438912"/>
-            <a:ext cx="438912" cy="438912"/>
-          </a:xfrm>
-          <a:prstGeom prst="rect">
-            <a:avLst/>
-          </a:prstGeom>
-          <a:noFill/>
-        </p:spPr>
-        <p:txBody>
-          <a:bodyPr wrap="none" lIns="73152" rIns="73152" tIns="73152" bIns="73152" anchor="ctr">
-            <a:spAutoFit/>
-          </a:bodyPr>
-          <a:lstStyle/>
-          <a:p>
-            <a:pPr algn="ctr"/>
-            <a:r>
-              <a:rPr sz="1300" b="1">
-                <a:solidFill>
-                  <a:srgbClr val="FFFFFF"/>
-                </a:solidFill>
-                <a:latin typeface="Aptos"/>
-              </a:rPr>
-              <a:t>06</a:t>
-            </a:r>
-          </a:p>
-        </p:txBody>
-      </p:sp>
-      <p:sp>
-        <p:nvSpPr>
-          <p:cNvPr id="6" name="Rounded Rectangle 5"/>
+          <p:cNvPr id="5" name="Rounded Rectangle 4"/>
           <p:cNvSpPr/>
           <p:nvPr/>
         </p:nvSpPr>
@@ -8369,7 +8194,7 @@
       </p:sp>
       <p:sp>
         <p:nvSpPr>
-          <p:cNvPr id="7" name="TextBox 6"/>
+          <p:cNvPr id="6" name="TextBox 5"/>
           <p:cNvSpPr txBox="1"/>
           <p:nvPr/>
         </p:nvSpPr>
@@ -8404,7 +8229,7 @@
       </p:sp>
       <p:graphicFrame>
         <p:nvGraphicFramePr>
-          <p:cNvPr id="8" name="Table 7"/>
+          <p:cNvPr id="7" name="Table 6"/>
           <p:cNvGraphicFramePr>
             <a:graphicFrameLocks noGrp="1"/>
           </p:cNvGraphicFramePr>
@@ -9018,7 +8843,7 @@
       </p:graphicFrame>
       <p:sp>
         <p:nvSpPr>
-          <p:cNvPr id="9" name="Rounded Rectangle 8"/>
+          <p:cNvPr id="8" name="Rounded Rectangle 7"/>
           <p:cNvSpPr/>
           <p:nvPr/>
         </p:nvSpPr>
@@ -9076,7 +8901,7 @@
       </p:sp>
       <p:sp>
         <p:nvSpPr>
-          <p:cNvPr id="10" name="TextBox 9"/>
+          <p:cNvPr id="9" name="TextBox 8"/>
           <p:cNvSpPr txBox="1"/>
           <p:nvPr/>
         </p:nvSpPr>
@@ -9244,42 +9069,7 @@
       </p:sp>
       <p:sp>
         <p:nvSpPr>
-          <p:cNvPr id="5" name="TextBox 4"/>
-          <p:cNvSpPr txBox="1"/>
-          <p:nvPr/>
-        </p:nvSpPr>
-        <p:spPr>
-          <a:xfrm>
-            <a:off x="11201400" y="438912"/>
-            <a:ext cx="438912" cy="438912"/>
-          </a:xfrm>
-          <a:prstGeom prst="rect">
-            <a:avLst/>
-          </a:prstGeom>
-          <a:noFill/>
-        </p:spPr>
-        <p:txBody>
-          <a:bodyPr wrap="none" lIns="73152" rIns="73152" tIns="73152" bIns="73152" anchor="ctr">
-            <a:spAutoFit/>
-          </a:bodyPr>
-          <a:lstStyle/>
-          <a:p>
-            <a:pPr algn="ctr"/>
-            <a:r>
-              <a:rPr sz="1300" b="1">
-                <a:solidFill>
-                  <a:srgbClr val="FFFFFF"/>
-                </a:solidFill>
-                <a:latin typeface="Aptos"/>
-              </a:rPr>
-              <a:t>07</a:t>
-            </a:r>
-          </a:p>
-        </p:txBody>
-      </p:sp>
-      <p:sp>
-        <p:nvSpPr>
-          <p:cNvPr id="6" name="Rounded Rectangle 5"/>
+          <p:cNvPr id="5" name="Rounded Rectangle 4"/>
           <p:cNvSpPr/>
           <p:nvPr/>
         </p:nvSpPr>
@@ -9333,7 +9123,7 @@
       </p:sp>
       <p:sp>
         <p:nvSpPr>
-          <p:cNvPr id="7" name="TextBox 6"/>
+          <p:cNvPr id="6" name="TextBox 5"/>
           <p:cNvSpPr txBox="1"/>
           <p:nvPr/>
         </p:nvSpPr>
@@ -9368,7 +9158,7 @@
       </p:sp>
       <p:graphicFrame>
         <p:nvGraphicFramePr>
-          <p:cNvPr id="8" name="Table 7"/>
+          <p:cNvPr id="7" name="Table 6"/>
           <p:cNvGraphicFramePr>
             <a:graphicFrameLocks noGrp="1"/>
           </p:cNvGraphicFramePr>
@@ -9982,7 +9772,7 @@
       </p:graphicFrame>
       <p:sp>
         <p:nvSpPr>
-          <p:cNvPr id="9" name="Rounded Rectangle 8"/>
+          <p:cNvPr id="8" name="Rounded Rectangle 7"/>
           <p:cNvSpPr/>
           <p:nvPr/>
         </p:nvSpPr>
@@ -10040,7 +9830,7 @@
       </p:sp>
       <p:sp>
         <p:nvSpPr>
-          <p:cNvPr id="10" name="TextBox 9"/>
+          <p:cNvPr id="9" name="TextBox 8"/>
           <p:cNvSpPr txBox="1"/>
           <p:nvPr/>
         </p:nvSpPr>
@@ -10208,42 +9998,7 @@
       </p:sp>
       <p:sp>
         <p:nvSpPr>
-          <p:cNvPr id="5" name="TextBox 4"/>
-          <p:cNvSpPr txBox="1"/>
-          <p:nvPr/>
-        </p:nvSpPr>
-        <p:spPr>
-          <a:xfrm>
-            <a:off x="11201400" y="438912"/>
-            <a:ext cx="438912" cy="438912"/>
-          </a:xfrm>
-          <a:prstGeom prst="rect">
-            <a:avLst/>
-          </a:prstGeom>
-          <a:noFill/>
-        </p:spPr>
-        <p:txBody>
-          <a:bodyPr wrap="none" lIns="73152" rIns="73152" tIns="73152" bIns="73152" anchor="ctr">
-            <a:spAutoFit/>
-          </a:bodyPr>
-          <a:lstStyle/>
-          <a:p>
-            <a:pPr algn="ctr"/>
-            <a:r>
-              <a:rPr sz="1300" b="1">
-                <a:solidFill>
-                  <a:srgbClr val="FFFFFF"/>
-                </a:solidFill>
-                <a:latin typeface="Aptos"/>
-              </a:rPr>
-              <a:t>08</a:t>
-            </a:r>
-          </a:p>
-        </p:txBody>
-      </p:sp>
-      <p:sp>
-        <p:nvSpPr>
-          <p:cNvPr id="6" name="Rounded Rectangle 5"/>
+          <p:cNvPr id="5" name="Rounded Rectangle 4"/>
           <p:cNvSpPr/>
           <p:nvPr/>
         </p:nvSpPr>
@@ -10297,7 +10052,7 @@
       </p:sp>
       <p:graphicFrame>
         <p:nvGraphicFramePr>
-          <p:cNvPr id="7" name="Table 6"/>
+          <p:cNvPr id="6" name="Table 5"/>
           <p:cNvGraphicFramePr>
             <a:graphicFrameLocks noGrp="1"/>
           </p:cNvGraphicFramePr>
@@ -10889,7 +10644,7 @@
       </p:graphicFrame>
       <p:sp>
         <p:nvSpPr>
-          <p:cNvPr id="8" name="TextBox 7"/>
+          <p:cNvPr id="7" name="TextBox 6"/>
           <p:cNvSpPr txBox="1"/>
           <p:nvPr/>
         </p:nvSpPr>
@@ -10924,7 +10679,7 @@
       </p:sp>
       <p:sp>
         <p:nvSpPr>
-          <p:cNvPr id="9" name="TextBox 8"/>
+          <p:cNvPr id="8" name="TextBox 7"/>
           <p:cNvSpPr txBox="1"/>
           <p:nvPr/>
         </p:nvSpPr>
@@ -11092,42 +10847,7 @@
       </p:sp>
       <p:sp>
         <p:nvSpPr>
-          <p:cNvPr id="5" name="TextBox 4"/>
-          <p:cNvSpPr txBox="1"/>
-          <p:nvPr/>
-        </p:nvSpPr>
-        <p:spPr>
-          <a:xfrm>
-            <a:off x="11201400" y="438912"/>
-            <a:ext cx="438912" cy="438912"/>
-          </a:xfrm>
-          <a:prstGeom prst="rect">
-            <a:avLst/>
-          </a:prstGeom>
-          <a:noFill/>
-        </p:spPr>
-        <p:txBody>
-          <a:bodyPr wrap="none" lIns="73152" rIns="73152" tIns="73152" bIns="73152" anchor="ctr">
-            <a:spAutoFit/>
-          </a:bodyPr>
-          <a:lstStyle/>
-          <a:p>
-            <a:pPr algn="ctr"/>
-            <a:r>
-              <a:rPr sz="1300" b="1">
-                <a:solidFill>
-                  <a:srgbClr val="FFFFFF"/>
-                </a:solidFill>
-                <a:latin typeface="Aptos"/>
-              </a:rPr>
-              <a:t>09</a:t>
-            </a:r>
-          </a:p>
-        </p:txBody>
-      </p:sp>
-      <p:sp>
-        <p:nvSpPr>
-          <p:cNvPr id="6" name="Rounded Rectangle 5"/>
+          <p:cNvPr id="5" name="Rounded Rectangle 4"/>
           <p:cNvSpPr/>
           <p:nvPr/>
         </p:nvSpPr>
@@ -11181,7 +10901,7 @@
       </p:sp>
       <p:sp>
         <p:nvSpPr>
-          <p:cNvPr id="7" name="Rounded Rectangle 6"/>
+          <p:cNvPr id="6" name="Rounded Rectangle 5"/>
           <p:cNvSpPr/>
           <p:nvPr/>
         </p:nvSpPr>
@@ -11226,7 +10946,7 @@
       </p:sp>
       <p:sp>
         <p:nvSpPr>
-          <p:cNvPr id="8" name="TextBox 7"/>
+          <p:cNvPr id="7" name="TextBox 6"/>
           <p:cNvSpPr txBox="1"/>
           <p:nvPr/>
         </p:nvSpPr>
@@ -11261,7 +10981,7 @@
       </p:sp>
       <p:sp>
         <p:nvSpPr>
-          <p:cNvPr id="9" name="TextBox 8"/>
+          <p:cNvPr id="8" name="TextBox 7"/>
           <p:cNvSpPr txBox="1"/>
           <p:nvPr/>
         </p:nvSpPr>
@@ -11296,7 +11016,7 @@
       </p:sp>
       <p:sp>
         <p:nvSpPr>
-          <p:cNvPr id="10" name="Rounded Rectangle 9"/>
+          <p:cNvPr id="9" name="Rounded Rectangle 8"/>
           <p:cNvSpPr/>
           <p:nvPr/>
         </p:nvSpPr>
@@ -11341,7 +11061,7 @@
       </p:sp>
       <p:sp>
         <p:nvSpPr>
-          <p:cNvPr id="11" name="TextBox 10"/>
+          <p:cNvPr id="10" name="TextBox 9"/>
           <p:cNvSpPr txBox="1"/>
           <p:nvPr/>
         </p:nvSpPr>
@@ -11376,7 +11096,7 @@
       </p:sp>
       <p:sp>
         <p:nvSpPr>
-          <p:cNvPr id="12" name="TextBox 11"/>
+          <p:cNvPr id="11" name="TextBox 10"/>
           <p:cNvSpPr txBox="1"/>
           <p:nvPr/>
         </p:nvSpPr>
@@ -11411,7 +11131,7 @@
       </p:sp>
       <p:sp>
         <p:nvSpPr>
-          <p:cNvPr id="13" name="Rounded Rectangle 12"/>
+          <p:cNvPr id="12" name="Rounded Rectangle 11"/>
           <p:cNvSpPr/>
           <p:nvPr/>
         </p:nvSpPr>
@@ -11456,7 +11176,7 @@
       </p:sp>
       <p:sp>
         <p:nvSpPr>
-          <p:cNvPr id="14" name="TextBox 13"/>
+          <p:cNvPr id="13" name="TextBox 12"/>
           <p:cNvSpPr txBox="1"/>
           <p:nvPr/>
         </p:nvSpPr>
@@ -11491,7 +11211,7 @@
       </p:sp>
       <p:sp>
         <p:nvSpPr>
-          <p:cNvPr id="15" name="TextBox 14"/>
+          <p:cNvPr id="14" name="TextBox 13"/>
           <p:cNvSpPr txBox="1"/>
           <p:nvPr/>
         </p:nvSpPr>
@@ -11526,7 +11246,7 @@
       </p:sp>
       <p:sp>
         <p:nvSpPr>
-          <p:cNvPr id="16" name="Rounded Rectangle 15"/>
+          <p:cNvPr id="15" name="Rounded Rectangle 14"/>
           <p:cNvSpPr/>
           <p:nvPr/>
         </p:nvSpPr>
@@ -11571,7 +11291,7 @@
       </p:sp>
       <p:sp>
         <p:nvSpPr>
-          <p:cNvPr id="17" name="TextBox 16"/>
+          <p:cNvPr id="16" name="TextBox 15"/>
           <p:cNvSpPr txBox="1"/>
           <p:nvPr/>
         </p:nvSpPr>
@@ -11606,7 +11326,7 @@
       </p:sp>
       <p:sp>
         <p:nvSpPr>
-          <p:cNvPr id="18" name="TextBox 17"/>
+          <p:cNvPr id="17" name="TextBox 16"/>
           <p:cNvSpPr txBox="1"/>
           <p:nvPr/>
         </p:nvSpPr>
@@ -11641,7 +11361,7 @@
       </p:sp>
       <p:sp>
         <p:nvSpPr>
-          <p:cNvPr id="19" name="TextBox 18"/>
+          <p:cNvPr id="18" name="TextBox 17"/>
           <p:cNvSpPr txBox="1"/>
           <p:nvPr/>
         </p:nvSpPr>
@@ -11676,7 +11396,7 @@
       </p:sp>
       <p:sp>
         <p:nvSpPr>
-          <p:cNvPr id="20" name="TextBox 19"/>
+          <p:cNvPr id="19" name="TextBox 18"/>
           <p:cNvSpPr txBox="1"/>
           <p:nvPr/>
         </p:nvSpPr>

</xml_diff>